<commit_message>
Completa el deck según la rúbrica oficial
Añade la declaración del problema de negocio (diapositiva 4) y los
bloques "Qué lo hará atractivo" y "Mejor que hoy" (diapositiva 6).
Actualiza la autoevaluación con los criterios de la rúbrica oficial.

Co-Authored-By: Claude Opus 5.5 <noreply@anthropic.com>
</commit_message>
<xml_diff>
--- a/asesor-experto-ia-escenario-c.pptx
+++ b/asesor-experto-ia-escenario-c.pptx
@@ -20884,7 +20884,7 @@
                 </a:solidFill>
                 <a:latin typeface="Open Sans Light"/>
               </a:rPr>
-              <a:t>Datos, privacidad y conectividad</a:t>
+              <a:t>Datos, privacidad, conectividad y ventaja frente a hoy</a:t>
             </a:r>
             <a:endParaRPr sz="3600">
               <a:solidFill>
@@ -20902,8 +20902,8 @@
         </p:nvSpPr>
         <p:spPr>
           <a:xfrm>
-            <a:off x="822960" y="2286000"/>
-            <a:ext cx="5303520" cy="6492240"/>
+            <a:off x="822960" y="2240280"/>
+            <a:ext cx="5303520" cy="4572000"/>
           </a:xfrm>
           <a:prstGeom prst="roundRect">
             <a:avLst>
@@ -20955,7 +20955,7 @@
             </a:r>
           </a:p>
           <a:p>
-            <a:pPr marL="438150" indent="-438150">
+            <a:pPr marL="361950" indent="-361950">
               <a:spcAft>
                 <a:spcPts val="600"/>
               </a:spcAft>
@@ -20966,7 +20966,7 @@
               <a:buChar char="•"/>
             </a:pPr>
             <a:r>
-              <a:rPr lang="es-ES" sz="2300" b="1" i="0">
+              <a:rPr lang="es-ES" sz="1900" b="1" i="0">
                 <a:solidFill>
                   <a:srgbClr val="0B0B0B"/>
                 </a:solidFill>
@@ -20975,7 +20975,7 @@
               <a:t>Más de las mismas:</a:t>
             </a:r>
             <a:r>
-              <a:rPr lang="es-ES" sz="2300" b="0" i="0">
+              <a:rPr lang="es-ES" sz="1900" b="0" i="0">
                 <a:solidFill>
                   <a:srgbClr val="0B0B0B"/>
                 </a:solidFill>
@@ -20985,7 +20985,7 @@
             </a:r>
           </a:p>
           <a:p>
-            <a:pPr marL="438150" indent="-438150">
+            <a:pPr marL="361950" indent="-361950">
               <a:spcAft>
                 <a:spcPts val="600"/>
               </a:spcAft>
@@ -20996,7 +20996,7 @@
               <a:buChar char="•"/>
             </a:pPr>
             <a:r>
-              <a:rPr lang="es-ES" sz="2300" b="1" i="0">
+              <a:rPr lang="es-ES" sz="1900" b="1" i="0">
                 <a:solidFill>
                   <a:srgbClr val="0B0B0B"/>
                 </a:solidFill>
@@ -21005,7 +21005,7 @@
               <a:t>Nuevas:</a:t>
             </a:r>
             <a:r>
-              <a:rPr lang="es-ES" sz="2300" b="0" i="0">
+              <a:rPr lang="es-ES" sz="1900" b="0" i="0">
                 <a:solidFill>
                   <a:srgbClr val="0B0B0B"/>
                 </a:solidFill>
@@ -21024,7 +21024,7 @@
         </p:nvSpPr>
         <p:spPr>
           <a:xfrm>
-            <a:off x="1078992" y="2505456"/>
+            <a:off x="1078992" y="2459736"/>
             <a:ext cx="566928" cy="566928"/>
           </a:xfrm>
           <a:prstGeom prst="ellipse">
@@ -21084,8 +21084,8 @@
         </p:nvSpPr>
         <p:spPr>
           <a:xfrm>
-            <a:off x="6492240" y="2286000"/>
-            <a:ext cx="5303520" cy="6492240"/>
+            <a:off x="6492240" y="2240280"/>
+            <a:ext cx="5303520" cy="4572000"/>
           </a:xfrm>
           <a:prstGeom prst="roundRect">
             <a:avLst>
@@ -21137,7 +21137,7 @@
             </a:r>
           </a:p>
           <a:p>
-            <a:pPr marL="438150" indent="-438150">
+            <a:pPr marL="361950" indent="-361950">
               <a:spcAft>
                 <a:spcPts val="600"/>
               </a:spcAft>
@@ -21148,7 +21148,7 @@
               <a:buChar char="•"/>
             </a:pPr>
             <a:r>
-              <a:rPr lang="es-ES" sz="2300" b="1" i="0">
+              <a:rPr lang="es-ES" sz="1900" b="1" i="0">
                 <a:solidFill>
                   <a:srgbClr val="0B0B0B"/>
                 </a:solidFill>
@@ -21157,7 +21157,7 @@
               <a:t>Nivel alto.</a:t>
             </a:r>
             <a:r>
-              <a:rPr lang="es-ES" sz="2300" b="0" i="0">
+              <a:rPr lang="es-ES" sz="1900" b="0" i="0">
                 <a:solidFill>
                   <a:srgbClr val="0B0B0B"/>
                 </a:solidFill>
@@ -21167,7 +21167,7 @@
             </a:r>
           </a:p>
           <a:p>
-            <a:pPr marL="438150" indent="-438150">
+            <a:pPr marL="361950" indent="-361950">
               <a:spcAft>
                 <a:spcPts val="600"/>
               </a:spcAft>
@@ -21178,7 +21178,7 @@
               <a:buChar char="•"/>
             </a:pPr>
             <a:r>
-              <a:rPr lang="es-ES" sz="2300" b="0" i="0">
+              <a:rPr lang="es-ES" sz="1900" b="0" i="0">
                 <a:solidFill>
                   <a:srgbClr val="0B0B0B"/>
                 </a:solidFill>
@@ -21197,7 +21197,7 @@
         </p:nvSpPr>
         <p:spPr>
           <a:xfrm>
-            <a:off x="6748272" y="2505456"/>
+            <a:off x="6748272" y="2459736"/>
             <a:ext cx="566928" cy="566928"/>
           </a:xfrm>
           <a:prstGeom prst="ellipse">
@@ -21257,8 +21257,8 @@
         </p:nvSpPr>
         <p:spPr>
           <a:xfrm>
-            <a:off x="12161520" y="2286000"/>
-            <a:ext cx="5303520" cy="6492240"/>
+            <a:off x="12161520" y="2240280"/>
+            <a:ext cx="5303520" cy="4572000"/>
           </a:xfrm>
           <a:prstGeom prst="roundRect">
             <a:avLst>
@@ -21310,7 +21310,7 @@
             </a:r>
           </a:p>
           <a:p>
-            <a:pPr marL="438150" indent="-438150">
+            <a:pPr marL="361950" indent="-361950">
               <a:spcAft>
                 <a:spcPts val="200"/>
               </a:spcAft>
@@ -21321,7 +21321,7 @@
               <a:buChar char="•"/>
             </a:pPr>
             <a:r>
-              <a:rPr lang="es-ES" sz="2300" b="0" i="0">
+              <a:rPr lang="es-ES" sz="1900" b="0" i="0">
                 <a:solidFill>
                   <a:srgbClr val="0B0B0B"/>
                 </a:solidFill>
@@ -21331,7 +21331,7 @@
             </a:r>
           </a:p>
           <a:p>
-            <a:pPr marL="438150" indent="-438150">
+            <a:pPr marL="361950" indent="-361950">
               <a:spcAft>
                 <a:spcPts val="200"/>
               </a:spcAft>
@@ -21342,7 +21342,7 @@
               <a:buChar char="•"/>
             </a:pPr>
             <a:r>
-              <a:rPr lang="es-ES" sz="2300" b="0" i="0">
+              <a:rPr lang="es-ES" sz="1900" b="0" i="0">
                 <a:solidFill>
                   <a:srgbClr val="0B0B0B"/>
                 </a:solidFill>
@@ -21352,7 +21352,7 @@
             </a:r>
           </a:p>
           <a:p>
-            <a:pPr marL="438150" indent="-438150">
+            <a:pPr marL="361950" indent="-361950">
               <a:spcAft>
                 <a:spcPts val="200"/>
               </a:spcAft>
@@ -21363,7 +21363,7 @@
               <a:buChar char="•"/>
             </a:pPr>
             <a:r>
-              <a:rPr lang="es-ES" sz="2300" b="0" i="0">
+              <a:rPr lang="es-ES" sz="1900" b="0" i="0">
                 <a:solidFill>
                   <a:srgbClr val="0B0B0B"/>
                 </a:solidFill>
@@ -21382,7 +21382,7 @@
         </p:nvSpPr>
         <p:spPr>
           <a:xfrm>
-            <a:off x="12417552" y="2505456"/>
+            <a:off x="12417552" y="2459736"/>
             <a:ext cx="566928" cy="566928"/>
           </a:xfrm>
           <a:prstGeom prst="ellipse">
@@ -21430,6 +21430,148 @@
                 <a:latin typeface="Open Sans"/>
               </a:rPr>
               <a:t>3</a:t>
+            </a:r>
+          </a:p>
+        </p:txBody>
+      </p:sp>
+      <p:sp>
+        <p:nvSpPr>
+          <p:cNvPr id="233" name="Qué lo hará atractivo"/>
+          <p:cNvSpPr/>
+          <p:nvPr/>
+        </p:nvSpPr>
+        <p:spPr>
+          <a:xfrm>
+            <a:off x="822960" y="7040880"/>
+            <a:ext cx="8138160" cy="1783080"/>
+          </a:xfrm>
+          <a:prstGeom prst="roundRect">
+            <a:avLst>
+              <a:gd name="adj" fmla="val 6000"/>
+            </a:avLst>
+          </a:prstGeom>
+          <a:solidFill>
+            <a:srgbClr val="171A53"/>
+          </a:solidFill>
+          <a:ln>
+            <a:noFill/>
+          </a:ln>
+          <a:effectLst/>
+        </p:spPr>
+        <p:style>
+          <a:lnRef idx="1">
+            <a:schemeClr val="accent1"/>
+          </a:lnRef>
+          <a:fillRef idx="3">
+            <a:schemeClr val="accent1"/>
+          </a:fillRef>
+          <a:effectRef idx="2">
+            <a:schemeClr val="accent1"/>
+          </a:effectRef>
+          <a:fontRef idx="minor">
+            <a:schemeClr val="lt1"/>
+          </a:fontRef>
+        </p:style>
+        <p:txBody>
+          <a:bodyPr rtlCol="0" anchor="ctr" wrap="square" lIns="274320" rIns="274320" tIns="274320" bIns="274320">
+            <a:noAutofit/>
+          </a:bodyPr>
+          <a:lstStyle/>
+          <a:p>
+            <a:pPr marL="0" indent="0">
+              <a:spcAft>
+                <a:spcPts val="0"/>
+              </a:spcAft>
+              <a:buNone/>
+            </a:pPr>
+            <a:r>
+              <a:rPr lang="es-ES" sz="1900" b="1" i="0">
+                <a:solidFill>
+                  <a:srgbClr val="FFFFFF"/>
+                </a:solidFill>
+                <a:latin typeface="Open Sans"/>
+              </a:rPr>
+              <a:t>Qué lo hará atractivo (o no).</a:t>
+            </a:r>
+            <a:r>
+              <a:rPr lang="es-ES" sz="1900" b="0" i="0">
+                <a:solidFill>
+                  <a:srgbClr val="FFFFFF"/>
+                </a:solidFill>
+                <a:latin typeface="Open Sans"/>
+              </a:rPr>
+              <a:t> Lo adoptarán si responde en su idioma, en segundos y con la fuente a la vista para comprobarlo. Lo abandonarán con una sola instrucción peligrosa o absurda: por eso las precauciones y las piezas las controla código verificable.</a:t>
+            </a:r>
+          </a:p>
+        </p:txBody>
+      </p:sp>
+      <p:sp>
+        <p:nvSpPr>
+          <p:cNvPr id="234" name="Mejor que hoy"/>
+          <p:cNvSpPr/>
+          <p:nvPr/>
+        </p:nvSpPr>
+        <p:spPr>
+          <a:xfrm>
+            <a:off x="9326880" y="7040880"/>
+            <a:ext cx="8138160" cy="1783080"/>
+          </a:xfrm>
+          <a:prstGeom prst="roundRect">
+            <a:avLst>
+              <a:gd name="adj" fmla="val 6000"/>
+            </a:avLst>
+          </a:prstGeom>
+          <a:solidFill>
+            <a:srgbClr val="EEEDFF"/>
+          </a:solidFill>
+          <a:ln>
+            <a:noFill/>
+          </a:ln>
+          <a:effectLst/>
+        </p:spPr>
+        <p:style>
+          <a:lnRef idx="1">
+            <a:schemeClr val="accent1"/>
+          </a:lnRef>
+          <a:fillRef idx="3">
+            <a:schemeClr val="accent1"/>
+          </a:fillRef>
+          <a:effectRef idx="2">
+            <a:schemeClr val="accent1"/>
+          </a:effectRef>
+          <a:fontRef idx="minor">
+            <a:schemeClr val="lt1"/>
+          </a:fontRef>
+        </p:style>
+        <p:txBody>
+          <a:bodyPr rtlCol="0" anchor="ctr" wrap="square" lIns="274320" rIns="274320" tIns="274320" bIns="274320">
+            <a:noAutofit/>
+          </a:bodyPr>
+          <a:lstStyle/>
+          <a:p>
+            <a:pPr marL="0" indent="0">
+              <a:spcAft>
+                <a:spcPts val="0"/>
+              </a:spcAft>
+              <a:buNone/>
+            </a:pPr>
+            <a:r>
+              <a:rPr lang="es-ES" sz="1900" b="1" i="0">
+                <a:solidFill>
+                  <a:srgbClr val="171A53"/>
+                </a:solidFill>
+                <a:latin typeface="Open Sans"/>
+              </a:rPr>
+              <a:t>Mejor que hoy.</a:t>
+            </a:r>
+            <a:r>
+              <a:rPr lang="es-ES" sz="1900" b="0" i="0">
+                <a:solidFill>
+                  <a:srgbClr val="171A53"/>
+                </a:solidFill>
+                <a:latin typeface="Open Sans"/>
+              </a:rPr>
+              <a:t> Hoy el técnico busca en inglés, lee varios artículos en el móvil y, si no lo resuelve, espera a soporte con la línea parada. Con el asesor recibe en minutos una respuesta guiada para su robot exacto, y solo escala lo que de verdad lo necesita.</a:t>
             </a:r>
           </a:p>
         </p:txBody>
@@ -26495,7 +26637,7 @@
           <p:nvPr/>
         </p:nvGraphicFramePr>
         <p:xfrm>
-          <a:off x="822960" y="2286000"/>
+          <a:off x="822960" y="3749039"/>
           <a:ext cx="16642080" cy="1463040"/>
         </p:xfrm>
         <a:graphic>
@@ -26523,7 +26665,7 @@
                         <a:buNone/>
                       </a:pPr>
                       <a:r>
-                        <a:rPr lang="es-ES" sz="2100" b="1" i="0">
+                        <a:rPr lang="es-ES" sz="1900" b="1" i="0">
                           <a:solidFill>
                             <a:srgbClr val="0B0B0B"/>
                           </a:solidFill>
@@ -26547,7 +26689,7 @@
                         <a:buNone/>
                       </a:pPr>
                       <a:r>
-                        <a:rPr lang="es-ES" sz="2100" b="1" i="0">
+                        <a:rPr lang="es-ES" sz="1900" b="1" i="0">
                           <a:solidFill>
                             <a:srgbClr val="0B0B0B"/>
                           </a:solidFill>
@@ -26571,7 +26713,7 @@
                         <a:buNone/>
                       </a:pPr>
                       <a:r>
-                        <a:rPr lang="es-ES" sz="2100" b="1" i="0">
+                        <a:rPr lang="es-ES" sz="1900" b="1" i="0">
                           <a:solidFill>
                             <a:srgbClr val="0B0B0B"/>
                           </a:solidFill>
@@ -26597,7 +26739,7 @@
                         <a:buNone/>
                       </a:pPr>
                       <a:r>
-                        <a:rPr lang="es-ES" sz="2100" b="1" i="0">
+                        <a:rPr lang="es-ES" sz="1900" b="1" i="0">
                           <a:solidFill>
                             <a:srgbClr val="0B0B0B"/>
                           </a:solidFill>
@@ -26614,7 +26756,7 @@
                         <a:buNone/>
                       </a:pPr>
                       <a:r>
-                        <a:rPr lang="es-ES" sz="2100" b="0" i="0">
+                        <a:rPr lang="es-ES" sz="1900" b="0" i="0">
                           <a:solidFill>
                             <a:srgbClr val="4A4D6E"/>
                           </a:solidFill>
@@ -26631,7 +26773,7 @@
                     <a:bodyPr vert="horz" wrap="square"/>
                     <a:lstStyle/>
                     <a:p>
-                      <a:pPr marL="400050" indent="-400050">
+                      <a:pPr marL="361950" indent="-361950">
                         <a:spcAft>
                           <a:spcPts val="200"/>
                         </a:spcAft>
@@ -26642,7 +26784,7 @@
                         <a:buAutoNum type="arabicPeriod"/>
                       </a:pPr>
                       <a:r>
-                        <a:rPr lang="es-ES" sz="2100" b="0" i="0">
+                        <a:rPr lang="es-ES" sz="1900" b="0" i="0">
                           <a:solidFill>
                             <a:srgbClr val="0B0B0B"/>
                           </a:solidFill>
@@ -26652,7 +26794,7 @@
                       </a:r>
                     </a:p>
                     <a:p>
-                      <a:pPr marL="400050" indent="-400050">
+                      <a:pPr marL="361950" indent="-361950">
                         <a:spcAft>
                           <a:spcPts val="200"/>
                         </a:spcAft>
@@ -26663,7 +26805,7 @@
                         <a:buAutoNum type="arabicPeriod"/>
                       </a:pPr>
                       <a:r>
-                        <a:rPr lang="es-ES" sz="2100" b="0" i="0">
+                        <a:rPr lang="es-ES" sz="1900" b="0" i="0">
                           <a:solidFill>
                             <a:srgbClr val="0B0B0B"/>
                           </a:solidFill>
@@ -26673,7 +26815,7 @@
                       </a:r>
                     </a:p>
                     <a:p>
-                      <a:pPr marL="400050" indent="-400050">
+                      <a:pPr marL="361950" indent="-361950">
                         <a:spcAft>
                           <a:spcPts val="200"/>
                         </a:spcAft>
@@ -26684,7 +26826,7 @@
                         <a:buAutoNum type="arabicPeriod"/>
                       </a:pPr>
                       <a:r>
-                        <a:rPr lang="es-ES" sz="2100" b="0" i="0">
+                        <a:rPr lang="es-ES" sz="1900" b="0" i="0">
                           <a:solidFill>
                             <a:srgbClr val="0B0B0B"/>
                           </a:solidFill>
@@ -26701,7 +26843,7 @@
                     <a:bodyPr vert="horz" wrap="square"/>
                     <a:lstStyle/>
                     <a:p>
-                      <a:pPr marL="400050" indent="-400050">
+                      <a:pPr marL="361950" indent="-361950">
                         <a:spcAft>
                           <a:spcPts val="200"/>
                         </a:spcAft>
@@ -26712,7 +26854,7 @@
                         <a:buChar char="•"/>
                       </a:pPr>
                       <a:r>
-                        <a:rPr lang="es-ES" sz="2100" b="0" i="0">
+                        <a:rPr lang="es-ES" sz="1900" b="0" i="0">
                           <a:solidFill>
                             <a:srgbClr val="0B0B0B"/>
                           </a:solidFill>
@@ -26722,7 +26864,7 @@
                       </a:r>
                     </a:p>
                     <a:p>
-                      <a:pPr marL="400050" indent="-400050">
+                      <a:pPr marL="361950" indent="-361950">
                         <a:spcAft>
                           <a:spcPts val="200"/>
                         </a:spcAft>
@@ -26733,7 +26875,7 @@
                         <a:buChar char="•"/>
                       </a:pPr>
                       <a:r>
-                        <a:rPr lang="es-ES" sz="2100" b="0" i="0">
+                        <a:rPr lang="es-ES" sz="1900" b="0" i="0">
                           <a:solidFill>
                             <a:srgbClr val="0B0B0B"/>
                           </a:solidFill>
@@ -26743,7 +26885,7 @@
                       </a:r>
                     </a:p>
                     <a:p>
-                      <a:pPr marL="400050" indent="-400050">
+                      <a:pPr marL="361950" indent="-361950">
                         <a:spcAft>
                           <a:spcPts val="200"/>
                         </a:spcAft>
@@ -26754,7 +26896,7 @@
                         <a:buChar char="•"/>
                       </a:pPr>
                       <a:r>
-                        <a:rPr lang="es-ES" sz="2100" b="0" i="0">
+                        <a:rPr lang="es-ES" sz="1900" b="0" i="0">
                           <a:solidFill>
                             <a:srgbClr val="0B0B0B"/>
                           </a:solidFill>
@@ -26780,7 +26922,7 @@
                         <a:buNone/>
                       </a:pPr>
                       <a:r>
-                        <a:rPr lang="es-ES" sz="2100" b="1" i="0">
+                        <a:rPr lang="es-ES" sz="1900" b="1" i="0">
                           <a:solidFill>
                             <a:srgbClr val="0B0B0B"/>
                           </a:solidFill>
@@ -26797,7 +26939,7 @@
                         <a:buNone/>
                       </a:pPr>
                       <a:r>
-                        <a:rPr lang="es-ES" sz="2100" b="0" i="0">
+                        <a:rPr lang="es-ES" sz="1900" b="0" i="0">
                           <a:solidFill>
                             <a:srgbClr val="4A4D6E"/>
                           </a:solidFill>
@@ -26814,7 +26956,7 @@
                     <a:bodyPr vert="horz" wrap="square"/>
                     <a:lstStyle/>
                     <a:p>
-                      <a:pPr marL="400050" indent="-400050">
+                      <a:pPr marL="361950" indent="-361950">
                         <a:spcAft>
                           <a:spcPts val="200"/>
                         </a:spcAft>
@@ -26825,7 +26967,7 @@
                         <a:buAutoNum type="arabicPeriod"/>
                       </a:pPr>
                       <a:r>
-                        <a:rPr lang="es-ES" sz="2100" b="0" i="0">
+                        <a:rPr lang="es-ES" sz="1900" b="0" i="0">
                           <a:solidFill>
                             <a:srgbClr val="0B0B0B"/>
                           </a:solidFill>
@@ -26835,7 +26977,7 @@
                       </a:r>
                     </a:p>
                     <a:p>
-                      <a:pPr marL="400050" indent="-400050">
+                      <a:pPr marL="361950" indent="-361950">
                         <a:spcAft>
                           <a:spcPts val="200"/>
                         </a:spcAft>
@@ -26846,7 +26988,7 @@
                         <a:buAutoNum type="arabicPeriod"/>
                       </a:pPr>
                       <a:r>
-                        <a:rPr lang="es-ES" sz="2100" b="0" i="0">
+                        <a:rPr lang="es-ES" sz="1900" b="0" i="0">
                           <a:solidFill>
                             <a:srgbClr val="0B0B0B"/>
                           </a:solidFill>
@@ -26856,7 +26998,7 @@
                       </a:r>
                     </a:p>
                     <a:p>
-                      <a:pPr marL="400050" indent="-400050">
+                      <a:pPr marL="361950" indent="-361950">
                         <a:spcAft>
                           <a:spcPts val="200"/>
                         </a:spcAft>
@@ -26867,7 +27009,7 @@
                         <a:buAutoNum type="arabicPeriod"/>
                       </a:pPr>
                       <a:r>
-                        <a:rPr lang="es-ES" sz="2100" b="0" i="0">
+                        <a:rPr lang="es-ES" sz="1900" b="0" i="0">
                           <a:solidFill>
                             <a:srgbClr val="0B0B0B"/>
                           </a:solidFill>
@@ -26884,7 +27026,7 @@
                     <a:bodyPr vert="horz" wrap="square"/>
                     <a:lstStyle/>
                     <a:p>
-                      <a:pPr marL="400050" indent="-400050">
+                      <a:pPr marL="361950" indent="-361950">
                         <a:spcAft>
                           <a:spcPts val="200"/>
                         </a:spcAft>
@@ -26895,7 +27037,7 @@
                         <a:buChar char="•"/>
                       </a:pPr>
                       <a:r>
-                        <a:rPr lang="es-ES" sz="2100" b="0" i="0">
+                        <a:rPr lang="es-ES" sz="1900" b="0" i="0">
                           <a:solidFill>
                             <a:srgbClr val="0B0B0B"/>
                           </a:solidFill>
@@ -26905,7 +27047,7 @@
                       </a:r>
                     </a:p>
                     <a:p>
-                      <a:pPr marL="400050" indent="-400050">
+                      <a:pPr marL="361950" indent="-361950">
                         <a:spcAft>
                           <a:spcPts val="200"/>
                         </a:spcAft>
@@ -26916,7 +27058,7 @@
                         <a:buChar char="•"/>
                       </a:pPr>
                       <a:r>
-                        <a:rPr lang="es-ES" sz="2100" b="0" i="0">
+                        <a:rPr lang="es-ES" sz="1900" b="0" i="0">
                           <a:solidFill>
                             <a:srgbClr val="0B0B0B"/>
                           </a:solidFill>
@@ -26926,7 +27068,7 @@
                       </a:r>
                     </a:p>
                     <a:p>
-                      <a:pPr marL="400050" indent="-400050">
+                      <a:pPr marL="361950" indent="-361950">
                         <a:spcAft>
                           <a:spcPts val="200"/>
                         </a:spcAft>
@@ -26937,7 +27079,7 @@
                         <a:buChar char="•"/>
                       </a:pPr>
                       <a:r>
-                        <a:rPr lang="es-ES" sz="2100" b="0" i="0">
+                        <a:rPr lang="es-ES" sz="1900" b="0" i="0">
                           <a:solidFill>
                             <a:srgbClr val="0B0B0B"/>
                           </a:solidFill>
@@ -26963,7 +27105,7 @@
                         <a:buNone/>
                       </a:pPr>
                       <a:r>
-                        <a:rPr lang="es-ES" sz="2100" b="1" i="0">
+                        <a:rPr lang="es-ES" sz="1900" b="1" i="0">
                           <a:solidFill>
                             <a:srgbClr val="0B0B0B"/>
                           </a:solidFill>
@@ -26980,7 +27122,7 @@
                     <a:bodyPr vert="horz" wrap="square"/>
                     <a:lstStyle/>
                     <a:p>
-                      <a:pPr marL="400050" indent="-400050">
+                      <a:pPr marL="361950" indent="-361950">
                         <a:spcAft>
                           <a:spcPts val="200"/>
                         </a:spcAft>
@@ -26991,7 +27133,7 @@
                         <a:buAutoNum type="arabicPeriod"/>
                       </a:pPr>
                       <a:r>
-                        <a:rPr lang="es-ES" sz="2100" b="0" i="0">
+                        <a:rPr lang="es-ES" sz="1900" b="0" i="0">
                           <a:solidFill>
                             <a:srgbClr val="0B0B0B"/>
                           </a:solidFill>
@@ -27001,7 +27143,7 @@
                       </a:r>
                     </a:p>
                     <a:p>
-                      <a:pPr marL="400050" indent="-400050">
+                      <a:pPr marL="361950" indent="-361950">
                         <a:spcAft>
                           <a:spcPts val="200"/>
                         </a:spcAft>
@@ -27012,7 +27154,7 @@
                         <a:buAutoNum type="arabicPeriod"/>
                       </a:pPr>
                       <a:r>
-                        <a:rPr lang="es-ES" sz="2100" b="0" i="0">
+                        <a:rPr lang="es-ES" sz="1900" b="0" i="0">
                           <a:solidFill>
                             <a:srgbClr val="0B0B0B"/>
                           </a:solidFill>
@@ -27022,7 +27164,7 @@
                       </a:r>
                     </a:p>
                     <a:p>
-                      <a:pPr marL="400050" indent="-400050">
+                      <a:pPr marL="361950" indent="-361950">
                         <a:spcAft>
                           <a:spcPts val="200"/>
                         </a:spcAft>
@@ -27033,7 +27175,7 @@
                         <a:buAutoNum type="arabicPeriod"/>
                       </a:pPr>
                       <a:r>
-                        <a:rPr lang="es-ES" sz="2100" b="0" i="0">
+                        <a:rPr lang="es-ES" sz="1900" b="0" i="0">
                           <a:solidFill>
                             <a:srgbClr val="0B0B0B"/>
                           </a:solidFill>
@@ -27050,7 +27192,7 @@
                     <a:bodyPr vert="horz" wrap="square"/>
                     <a:lstStyle/>
                     <a:p>
-                      <a:pPr marL="400050" indent="-400050">
+                      <a:pPr marL="361950" indent="-361950">
                         <a:spcAft>
                           <a:spcPts val="200"/>
                         </a:spcAft>
@@ -27061,7 +27203,7 @@
                         <a:buChar char="•"/>
                       </a:pPr>
                       <a:r>
-                        <a:rPr lang="es-ES" sz="2100" b="0" i="0">
+                        <a:rPr lang="es-ES" sz="1900" b="0" i="0">
                           <a:solidFill>
                             <a:srgbClr val="0B0B0B"/>
                           </a:solidFill>
@@ -27071,7 +27213,7 @@
                       </a:r>
                     </a:p>
                     <a:p>
-                      <a:pPr marL="400050" indent="-400050">
+                      <a:pPr marL="361950" indent="-361950">
                         <a:spcAft>
                           <a:spcPts val="200"/>
                         </a:spcAft>
@@ -27082,7 +27224,7 @@
                         <a:buChar char="•"/>
                       </a:pPr>
                       <a:r>
-                        <a:rPr lang="es-ES" sz="2100" b="0" i="0">
+                        <a:rPr lang="es-ES" sz="1900" b="0" i="0">
                           <a:solidFill>
                             <a:srgbClr val="0B0B0B"/>
                           </a:solidFill>
@@ -27092,7 +27234,7 @@
                       </a:r>
                     </a:p>
                     <a:p>
-                      <a:pPr marL="400050" indent="-400050">
+                      <a:pPr marL="361950" indent="-361950">
                         <a:spcAft>
                           <a:spcPts val="200"/>
                         </a:spcAft>
@@ -27103,7 +27245,7 @@
                         <a:buChar char="•"/>
                       </a:pPr>
                       <a:r>
-                        <a:rPr lang="es-ES" sz="2100" b="0" i="0">
+                        <a:rPr lang="es-ES" sz="1900" b="0" i="0">
                           <a:solidFill>
                             <a:srgbClr val="0B0B0B"/>
                           </a:solidFill>
@@ -27120,6 +27262,77 @@
           </a:graphicData>
         </a:graphic>
       </p:graphicFrame>
+      <p:sp>
+        <p:nvSpPr>
+          <p:cNvPr id="220" name="Problema de negocio"/>
+          <p:cNvSpPr/>
+          <p:nvPr/>
+        </p:nvSpPr>
+        <p:spPr>
+          <a:xfrm>
+            <a:off x="822960" y="2194560"/>
+            <a:ext cx="16642080" cy="1325880"/>
+          </a:xfrm>
+          <a:prstGeom prst="roundRect">
+            <a:avLst>
+              <a:gd name="adj" fmla="val 6000"/>
+            </a:avLst>
+          </a:prstGeom>
+          <a:solidFill>
+            <a:srgbClr val="171A53"/>
+          </a:solidFill>
+          <a:ln>
+            <a:noFill/>
+          </a:ln>
+          <a:effectLst/>
+        </p:spPr>
+        <p:style>
+          <a:lnRef idx="1">
+            <a:schemeClr val="accent1"/>
+          </a:lnRef>
+          <a:fillRef idx="3">
+            <a:schemeClr val="accent1"/>
+          </a:fillRef>
+          <a:effectRef idx="2">
+            <a:schemeClr val="accent1"/>
+          </a:effectRef>
+          <a:fontRef idx="minor">
+            <a:schemeClr val="lt1"/>
+          </a:fontRef>
+        </p:style>
+        <p:txBody>
+          <a:bodyPr rtlCol="0" anchor="ctr" wrap="square" lIns="274320" rIns="274320" tIns="274320" bIns="274320">
+            <a:noAutofit/>
+          </a:bodyPr>
+          <a:lstStyle/>
+          <a:p>
+            <a:pPr marL="0" indent="0">
+              <a:spcAft>
+                <a:spcPts val="0"/>
+              </a:spcAft>
+              <a:buNone/>
+            </a:pPr>
+            <a:r>
+              <a:rPr lang="es-ES" sz="2100" b="1" i="0">
+                <a:solidFill>
+                  <a:srgbClr val="FFFFFF"/>
+                </a:solidFill>
+                <a:latin typeface="Open Sans"/>
+              </a:rPr>
+              <a:t>Problema de negocio:</a:t>
+            </a:r>
+            <a:r>
+              <a:rPr lang="es-ES" sz="2100" b="0" i="0">
+                <a:solidFill>
+                  <a:srgbClr val="FFFFFF"/>
+                </a:solidFill>
+                <a:latin typeface="Open Sans"/>
+              </a:rPr>
+              <a:t> nuestros clientes pierden horas de producción porque sus técnicos no encuentran a tiempo cómo configurar o reparar los robots: la información está en una base de 7.500 artículos solo en inglés, difícil de buscar desde el móvil, y los casos complejos acaban escalados al soporte de la empresa.</a:t>
+            </a:r>
+          </a:p>
+        </p:txBody>
+      </p:sp>
     </p:spTree>
   </p:cSld>
   <p:clrMapOvr>

</xml_diff>